<commit_message>
SP 25 calendar and touch up.  Demo Prep
</commit_message>
<xml_diff>
--- a/Slides/Demo_Prep.pptx
+++ b/Slides/Demo_Prep.pptx
@@ -5,7 +5,7 @@
     <p:sldMasterId id="2147484209" r:id="rId1"/>
   </p:sldMasterIdLst>
   <p:notesMasterIdLst>
-    <p:notesMasterId r:id="rId11"/>
+    <p:notesMasterId r:id="rId12"/>
   </p:notesMasterIdLst>
   <p:sldIdLst>
     <p:sldId id="256" r:id="rId2"/>
@@ -17,6 +17,7 @@
     <p:sldId id="262" r:id="rId8"/>
     <p:sldId id="263" r:id="rId9"/>
     <p:sldId id="264" r:id="rId10"/>
+    <p:sldId id="265" r:id="rId11"/>
   </p:sldIdLst>
   <p:sldSz cx="12192000" cy="6858000"/>
   <p:notesSz cx="7315200" cy="9601200"/>
@@ -216,7 +217,7 @@
           <a:p>
             <a:fld id="{05DA5B87-4786-42E8-8BFB-5A9FAB7B5E71}" type="datetimeFigureOut">
               <a:rPr lang="en-US" smtClean="0"/>
-              <a:t>2/6/2023</a:t>
+              <a:t>12/4/2024</a:t>
             </a:fld>
             <a:endParaRPr lang="en-US"/>
           </a:p>
@@ -1102,7 +1103,7 @@
             <a:fld id="{B61BEF0D-F0BB-DE4B-95CE-6DB70DBA9567}" type="datetimeFigureOut">
               <a:rPr lang="en-US" smtClean="0"/>
               <a:pPr/>
-              <a:t>2/6/2023</a:t>
+              <a:t>12/4/2024</a:t>
             </a:fld>
             <a:endParaRPr lang="en-US" dirty="0"/>
           </a:p>
@@ -1293,7 +1294,7 @@
           <a:p>
             <a:fld id="{55C6B4A9-1611-4792-9094-5F34BCA07E0B}" type="datetimeFigureOut">
               <a:rPr lang="en-US" smtClean="0"/>
-              <a:t>2/6/2023</a:t>
+              <a:t>12/4/2024</a:t>
             </a:fld>
             <a:endParaRPr lang="en-US" dirty="0"/>
           </a:p>
@@ -1469,7 +1470,7 @@
             <a:fld id="{B61BEF0D-F0BB-DE4B-95CE-6DB70DBA9567}" type="datetimeFigureOut">
               <a:rPr lang="en-US" smtClean="0"/>
               <a:pPr/>
-              <a:t>2/6/2023</a:t>
+              <a:t>12/4/2024</a:t>
             </a:fld>
             <a:endParaRPr lang="en-US" dirty="0"/>
           </a:p>
@@ -1612,7 +1613,7 @@
           <a:p>
             <a:fld id="{42A54C80-263E-416B-A8E0-580EDEADCBDC}" type="datetimeFigureOut">
               <a:rPr lang="en-US" smtClean="0"/>
-              <a:t>2/6/2023</a:t>
+              <a:t>12/4/2024</a:t>
             </a:fld>
             <a:endParaRPr lang="en-US" dirty="0"/>
           </a:p>
@@ -1860,7 +1861,7 @@
             <a:fld id="{B61BEF0D-F0BB-DE4B-95CE-6DB70DBA9567}" type="datetimeFigureOut">
               <a:rPr lang="en-US" smtClean="0"/>
               <a:pPr/>
-              <a:t>2/6/2023</a:t>
+              <a:t>12/4/2024</a:t>
             </a:fld>
             <a:endParaRPr lang="en-US" dirty="0"/>
           </a:p>
@@ -2260,7 +2261,7 @@
           <a:p>
             <a:fld id="{42A54C80-263E-416B-A8E0-580EDEADCBDC}" type="datetimeFigureOut">
               <a:rPr lang="en-US" smtClean="0"/>
-              <a:t>2/6/2023</a:t>
+              <a:t>12/4/2024</a:t>
             </a:fld>
             <a:endParaRPr lang="en-US" dirty="0"/>
           </a:p>
@@ -2699,7 +2700,7 @@
             <a:fld id="{B61BEF0D-F0BB-DE4B-95CE-6DB70DBA9567}" type="datetimeFigureOut">
               <a:rPr lang="en-US" smtClean="0"/>
               <a:pPr/>
-              <a:t>2/6/2023</a:t>
+              <a:t>12/4/2024</a:t>
             </a:fld>
             <a:endParaRPr lang="en-US" dirty="0"/>
           </a:p>
@@ -2796,7 +2797,7 @@
             <a:fld id="{B61BEF0D-F0BB-DE4B-95CE-6DB70DBA9567}" type="datetimeFigureOut">
               <a:rPr lang="en-US" smtClean="0"/>
               <a:pPr/>
-              <a:t>2/6/2023</a:t>
+              <a:t>12/4/2024</a:t>
             </a:fld>
             <a:endParaRPr lang="en-US" dirty="0"/>
           </a:p>
@@ -2911,7 +2912,7 @@
             <a:fld id="{B61BEF0D-F0BB-DE4B-95CE-6DB70DBA9567}" type="datetimeFigureOut">
               <a:rPr lang="en-US" smtClean="0"/>
               <a:pPr/>
-              <a:t>2/6/2023</a:t>
+              <a:t>12/4/2024</a:t>
             </a:fld>
             <a:endParaRPr lang="en-US" dirty="0"/>
           </a:p>
@@ -3180,7 +3181,7 @@
           <a:p>
             <a:fld id="{42A54C80-263E-416B-A8E0-580EDEADCBDC}" type="datetimeFigureOut">
               <a:rPr lang="en-US" smtClean="0"/>
-              <a:t>2/6/2023</a:t>
+              <a:t>12/4/2024</a:t>
             </a:fld>
             <a:endParaRPr lang="en-US" dirty="0"/>
           </a:p>
@@ -3382,7 +3383,7 @@
             <a:fld id="{B61BEF0D-F0BB-DE4B-95CE-6DB70DBA9567}" type="datetimeFigureOut">
               <a:rPr lang="en-US" smtClean="0"/>
               <a:pPr/>
-              <a:t>2/6/2023</a:t>
+              <a:t>12/4/2024</a:t>
             </a:fld>
             <a:endParaRPr lang="en-US" dirty="0"/>
           </a:p>
@@ -4473,7 +4474,7 @@
             <a:fld id="{B61BEF0D-F0BB-DE4B-95CE-6DB70DBA9567}" type="datetimeFigureOut">
               <a:rPr lang="en-US" smtClean="0"/>
               <a:pPr/>
-              <a:t>2/6/2023</a:t>
+              <a:t>12/4/2024</a:t>
             </a:fld>
             <a:endParaRPr lang="en-US" dirty="0"/>
           </a:p>
@@ -4940,6 +4941,123 @@
 </p:sld>
 </file>
 
+<file path=ppt/slides/slide10.xml><?xml version="1.0" encoding="utf-8"?>
+<p:sld xmlns:a="http://schemas.openxmlformats.org/drawingml/2006/main" xmlns:r="http://schemas.openxmlformats.org/officeDocument/2006/relationships" xmlns:p="http://schemas.openxmlformats.org/presentationml/2006/main">
+  <p:cSld>
+    <p:spTree>
+      <p:nvGrpSpPr>
+        <p:cNvPr id="1" name=""/>
+        <p:cNvGrpSpPr/>
+        <p:nvPr/>
+      </p:nvGrpSpPr>
+      <p:grpSpPr>
+        <a:xfrm>
+          <a:off x="0" y="0"/>
+          <a:ext cx="0" cy="0"/>
+          <a:chOff x="0" y="0"/>
+          <a:chExt cx="0" cy="0"/>
+        </a:xfrm>
+      </p:grpSpPr>
+      <p:sp>
+        <p:nvSpPr>
+          <p:cNvPr id="2" name="Content Placeholder 1"/>
+          <p:cNvSpPr>
+            <a:spLocks noGrp="1"/>
+          </p:cNvSpPr>
+          <p:nvPr>
+            <p:ph idx="1"/>
+          </p:nvPr>
+        </p:nvSpPr>
+        <p:spPr>
+          <a:xfrm>
+            <a:off x="609600" y="1204857"/>
+            <a:ext cx="10972800" cy="4991548"/>
+          </a:xfrm>
+        </p:spPr>
+        <p:txBody>
+          <a:bodyPr>
+            <a:normAutofit/>
+          </a:bodyPr>
+          <a:lstStyle/>
+          <a:p>
+            <a:r>
+              <a:rPr lang="en-US" dirty="0" smtClean="0"/>
+              <a:t>Have </a:t>
+            </a:r>
+            <a:r>
+              <a:rPr lang="en-US" dirty="0" smtClean="0"/>
+              <a:t>the whole team materially participate in some way</a:t>
+            </a:r>
+          </a:p>
+          <a:p>
+            <a:r>
+              <a:rPr lang="en-US" dirty="0" smtClean="0"/>
+              <a:t>Have the demo </a:t>
+            </a:r>
+            <a:r>
+              <a:rPr lang="en-US" dirty="0" smtClean="0"/>
+              <a:t>portion run </a:t>
+            </a:r>
+            <a:r>
+              <a:rPr lang="en-US" dirty="0" smtClean="0"/>
+              <a:t>between 4 and 5 </a:t>
+            </a:r>
+            <a:r>
+              <a:rPr lang="en-US" dirty="0" smtClean="0"/>
+              <a:t>minutes</a:t>
+            </a:r>
+          </a:p>
+          <a:p>
+            <a:r>
+              <a:rPr lang="en-US" dirty="0" smtClean="0"/>
+              <a:t>Make sure the game sound levels are loud enough to hear but not so loud that we can’t hear you talk over them</a:t>
+            </a:r>
+          </a:p>
+          <a:p>
+            <a:r>
+              <a:rPr lang="en-US" dirty="0" smtClean="0"/>
+              <a:t>Make it look practiced and smooth</a:t>
+            </a:r>
+            <a:endParaRPr lang="en-US" dirty="0"/>
+          </a:p>
+        </p:txBody>
+      </p:sp>
+      <p:sp>
+        <p:nvSpPr>
+          <p:cNvPr id="3" name="Title 2"/>
+          <p:cNvSpPr>
+            <a:spLocks noGrp="1"/>
+          </p:cNvSpPr>
+          <p:nvPr>
+            <p:ph type="title"/>
+          </p:nvPr>
+        </p:nvSpPr>
+        <p:spPr/>
+        <p:txBody>
+          <a:bodyPr/>
+          <a:lstStyle/>
+          <a:p>
+            <a:r>
+              <a:rPr lang="en-US" dirty="0" smtClean="0"/>
+              <a:t>How not to lose points</a:t>
+            </a:r>
+            <a:endParaRPr lang="en-US" dirty="0"/>
+          </a:p>
+        </p:txBody>
+      </p:sp>
+    </p:spTree>
+    <p:extLst>
+      <p:ext uri="{BB962C8B-B14F-4D97-AF65-F5344CB8AC3E}">
+        <p14:creationId xmlns:p14="http://schemas.microsoft.com/office/powerpoint/2010/main" val="672520271"/>
+      </p:ext>
+    </p:extLst>
+  </p:cSld>
+  <p:clrMapOvr>
+    <a:masterClrMapping/>
+  </p:clrMapOvr>
+</p:sld>
+</file>
+
 <file path=ppt/slides/slide2.xml><?xml version="1.0" encoding="utf-8"?>
 <p:sld xmlns:a="http://schemas.openxmlformats.org/drawingml/2006/main" xmlns:r="http://schemas.openxmlformats.org/officeDocument/2006/relationships" xmlns:p="http://schemas.openxmlformats.org/presentationml/2006/main">
   <p:cSld>
@@ -4986,8 +5104,25 @@
           <a:p>
             <a:r>
               <a:rPr lang="en-US" dirty="0" smtClean="0"/>
-              <a:t>5 minute (max) demo</a:t>
-            </a:r>
+              <a:t>5 minute (max) </a:t>
+            </a:r>
+            <a:r>
+              <a:rPr lang="en-US" dirty="0" smtClean="0"/>
+              <a:t>demo</a:t>
+            </a:r>
+          </a:p>
+          <a:p>
+            <a:endParaRPr lang="en-US" dirty="0"/>
+          </a:p>
+          <a:p>
+            <a:pPr marL="109728" indent="0">
+              <a:buNone/>
+            </a:pPr>
+            <a:r>
+              <a:rPr lang="en-US" dirty="0" smtClean="0"/>
+              <a:t>(Those time buckets are independent of each other; time spent introducing the team and listing the upcoming features is separate from the time spent running the live demo.)</a:t>
+            </a:r>
+            <a:endParaRPr lang="en-US" dirty="0" smtClean="0"/>
           </a:p>
           <a:p>
             <a:endParaRPr lang="en-US" dirty="0"/>
@@ -5092,16 +5227,36 @@
           <a:p>
             <a:r>
               <a:rPr lang="en-US" dirty="0" smtClean="0"/>
-              <a:t>Email to me by Friday, </a:t>
+              <a:t>Email to me by </a:t>
             </a:r>
             <a:r>
               <a:rPr lang="en-US" dirty="0" smtClean="0"/>
-              <a:t>21-April-2023, </a:t>
+              <a:t>Monday</a:t>
+            </a:r>
+            <a:r>
+              <a:rPr lang="en-US" smtClean="0"/>
+              <a:t>, 2-December-2024, </a:t>
             </a:r>
             <a:r>
               <a:rPr lang="en-US" dirty="0" smtClean="0"/>
               <a:t>midnight.   </a:t>
             </a:r>
+            <a:endParaRPr lang="en-US" dirty="0" smtClean="0"/>
+          </a:p>
+          <a:p>
+            <a:r>
+              <a:rPr lang="en-US" dirty="0" smtClean="0"/>
+              <a:t>PowerPoint </a:t>
+            </a:r>
+            <a:r>
+              <a:rPr lang="en-US" dirty="0" err="1" smtClean="0"/>
+              <a:t>pptx</a:t>
+            </a:r>
+            <a:r>
+              <a:rPr lang="en-US" dirty="0" smtClean="0"/>
+              <a:t> format only</a:t>
+            </a:r>
+            <a:endParaRPr lang="en-US" dirty="0" smtClean="0"/>
           </a:p>
           <a:p>
             <a:r>
@@ -5798,7 +5953,7 @@
         <p:spPr>
           <a:xfrm>
             <a:off x="609600" y="1204857"/>
-            <a:ext cx="10972800" cy="4991548"/>
+            <a:ext cx="10972800" cy="4973874"/>
           </a:xfrm>
         </p:spPr>
         <p:txBody>
@@ -5827,21 +5982,15 @@
           <a:p>
             <a:r>
               <a:rPr lang="en-US" dirty="0" smtClean="0"/>
-              <a:t>Slide in some commentary about the tech underpinning the features as you go over the features</a:t>
-            </a:r>
-          </a:p>
-          <a:p>
+              <a:t>Slide in some commentary about the tech underpinning the features as you go over the </a:t>
+            </a:r>
             <a:r>
               <a:rPr lang="en-US" dirty="0" smtClean="0"/>
-              <a:t>Have the whole team materially participate in some way</a:t>
-            </a:r>
-          </a:p>
-          <a:p>
-            <a:r>
-              <a:rPr lang="en-US" dirty="0" smtClean="0"/>
-              <a:t>Have the demo run between 4 and 5 minutes</a:t>
-            </a:r>
-            <a:endParaRPr lang="en-US" dirty="0"/>
+              <a:t>features</a:t>
+            </a:r>
+          </a:p>
+          <a:p>
+            <a:endParaRPr lang="en-US" dirty="0" smtClean="0"/>
           </a:p>
         </p:txBody>
       </p:sp>

</xml_diff>